<commit_message>
Commit do que funcionou no meu note
Algumas alterações que tive que fazer para que o programa rodasse direito no meu pc
</commit_message>
<xml_diff>
--- a/Sprint_Review_Inteligente.pptx
+++ b/Sprint_Review_Inteligente.pptx
@@ -3192,19 +3192,31 @@
           <a:p>
             <a:pPr lvl="1"/>
             <a:r>
-              <a:t>Correção de erro no serviço de dados</a:t>
+              <a:t>Microsserviço base para apresentações implementado</a:t>
             </a:r>
           </a:p>
           <a:p>
             <a:pPr lvl="1"/>
             <a:r>
-              <a:t>Refinamento da interface do usuário</a:t>
+              <a:t>Corrigido erro de integração na geração de slides</a:t>
             </a:r>
           </a:p>
           <a:p>
             <a:pPr lvl="1"/>
             <a:r>
-              <a:t>Integração do serviço de e-mail</a:t>
+              <a:t>API Keys movidas para variáveis de ambiente</a:t>
+            </a:r>
+          </a:p>
+          <a:p>
+            <a:pPr lvl="1"/>
+            <a:r>
+              <a:t>Validado primeiro deploy local para testes de geração de arquivos</a:t>
+            </a:r>
+          </a:p>
+          <a:p>
+            <a:pPr lvl="1"/>
+            <a:r>
+              <a:t>Ambiente colaborativo e estrutura do backlog inicial configurados</a:t>
             </a:r>
           </a:p>
         </p:txBody>

</xml_diff>